<commit_message>
ASELSAN sunum metinleri sadelestirildi ve akici Turkceye uyarlandi
</commit_message>
<xml_diff>
--- a/Kurumsal/Sunumlar/Trustia_ASELSAN_Girisim_Sunumu.pptx
+++ b/Kurumsal/Sunumlar/Trustia_ASELSAN_Girisim_Sunumu.pptx
@@ -4693,7 +4693,7 @@
               </a:defRPr>
             </a:pPr>
             <a:r>
-              <a:t>TRUSTIA TEKNOLOJİ A.Ş.</a:t>
+              <a:t>TRUSTIA TEKNOLOJİ</a:t>
             </a:r>
           </a:p>
           <a:p>
@@ -4705,7 +4705,7 @@
               </a:defRPr>
             </a:pPr>
             <a:r>
-              <a:t>Milli Otonom Sürüş Platformu &amp; İnsansız Kara Aracı Beyni</a:t>
+              <a:t>Milli Otonom Sürüş Yazılımı &amp; İnsansız Araç Beyni</a:t>
             </a:r>
           </a:p>
           <a:p>
@@ -4717,7 +4717,7 @@
               </a:defRPr>
             </a:pPr>
             <a:r>
-              <a:t>GPS Olmadan Lazerle Haritalama Yapan ve Elektronik Karıştırmadan Etkilenmeyen Yerli Yazılım</a:t>
+              <a:t>Uydudan Bağımsız Lazerle Harita Çıkaran ve Sinyal Kesilmesinden Etkilenmeyen Yerli Sistem</a:t>
             </a:r>
           </a:p>
         </p:txBody>
@@ -4876,7 +4876,7 @@
               </a:defRPr>
             </a:pPr>
             <a:r>
-              <a:t>PLANLANAN YOL HARİTASI: 2026 - 2028 Hedeflerimiz</a:t>
+              <a:t>YOL HARİTASI: 2026 - 2028 Hedeflerimiz</a:t>
             </a:r>
           </a:p>
         </p:txBody>
@@ -5001,7 +5001,7 @@
               </a:defRPr>
             </a:pPr>
             <a:r>
-              <a:t>ŞU ANKİ DURUM</a:t>
+              <a:t>ŞU AN</a:t>
             </a:r>
           </a:p>
           <a:p>
@@ -5013,7 +5013,7 @@
               </a:defRPr>
             </a:pPr>
             <a:r>
-              <a:t>Çalışır Prototip</a:t>
+              <a:t>Çalışır Sistem</a:t>
             </a:r>
           </a:p>
           <a:p>
@@ -5025,7 +5025,7 @@
               </a:defRPr>
             </a:pPr>
             <a:r>
-              <a:t>16.000 satır yerli kod, 1.301 birim test ile doğrulandı. ASELSAN Tedarikçi Portalı Yazılım Ön Onayı alındı.</a:t>
+              <a:t>16 bin satır yerli kod, 1.301 test ile doğrulandı. ASELSAN Tedarikçi Portalı Yazılım Ön Onayı alındı.</a:t>
             </a:r>
           </a:p>
         </p:txBody>
@@ -5105,7 +5105,7 @@
               </a:defRPr>
             </a:pPr>
             <a:r>
-              <a:t>YIL SONU HEDEFİ</a:t>
+              <a:t>YIL SONU</a:t>
             </a:r>
           </a:p>
           <a:p>
@@ -5117,7 +5117,7 @@
               </a:defRPr>
             </a:pPr>
             <a:r>
-              <a:t>ASELSAN Saha Testi</a:t>
+              <a:t>Saha Denemesi</a:t>
             </a:r>
           </a:p>
           <a:p>
@@ -5129,7 +5129,7 @@
               </a:defRPr>
             </a:pPr>
             <a:r>
-              <a:t>Axcelerate kabulü ile ASELSAN taktik aracında kapalı alanda ve arazide ilk gerçek saha sürüş testinin yapılması.</a:t>
+              <a:t>Axcelerate programı ile ASELSAN taktik aracında kapalı alanda ve arazide ilk sürüş denemesinin yapılması.</a:t>
             </a:r>
           </a:p>
         </p:txBody>
@@ -5233,7 +5233,7 @@
               </a:defRPr>
             </a:pPr>
             <a:r>
-              <a:t>İlk 10 taktik kara aracı için seri yazılım lisans teslimatı ve komuta ekranı tam entegrasyonu.</a:t>
+              <a:t>İlk 10 taktik kara aracı için seri yazılım lisans teslimatı ve kontrol ekranı tam uyumu.</a:t>
             </a:r>
           </a:p>
         </p:txBody>
@@ -5337,7 +5337,7 @@
               </a:defRPr>
             </a:pPr>
             <a:r>
-              <a:t>Çoklu araçların sürü halinde birlikte hareket etmesi ve dost/müttefik ülkelere yazılım ihracatı.</a:t>
+              <a:t>Araçların sürü halinde birlikte hareket etmesi ve dost ülkelere yazılım satışı.</a:t>
             </a:r>
           </a:p>
         </p:txBody>
@@ -5710,11 +5710,11 @@
             </a:r>
             <a:br/>
             <a:r>
-              <a:t>• Lazer tarayıcılar (LiDAR), sensörler, gömülü bilgisayarlar ve araç içi CAN haberleşme uzmanı.</a:t>
+              <a:t>• Lazer tarayıcılar (LiDAR), sensörler, gömülü bilgisayarlar ve araç içi haberleşme uzmanı.</a:t>
             </a:r>
             <a:br/>
             <a:r>
-              <a:t>• Donanım Entegrasyonu ve Saha Testleri Lideri.</a:t>
+              <a:t>• Donanım Kurulumu ve Saha Testleri Lideri.</a:t>
             </a:r>
           </a:p>
         </p:txBody>
@@ -5939,7 +5939,7 @@
               </a:defRPr>
             </a:pPr>
             <a:r>
-              <a:t>1. ASELSAN Araçlarında Ortak Saha Testi</a:t>
+              <a:t>1. ASELSAN Araçlarında Ortak Saha Denemesi</a:t>
             </a:r>
           </a:p>
           <a:p>
@@ -5951,7 +5951,7 @@
               </a:defRPr>
             </a:pPr>
             <a:r>
-              <a:t>ASELSAN'ın mevcut insansız kara araçlarında (örneğin Aslan veya Ertuğrul) yazılımımızı araca yükleyip arazide birlikte test etmek.</a:t>
+              <a:t>ASELSAN'ın mevcut insansız kara araçlarında yazılımımızı araca yükleyip arazide birlikte denemek.</a:t>
             </a:r>
           </a:p>
         </p:txBody>
@@ -6031,7 +6031,7 @@
               </a:defRPr>
             </a:pPr>
             <a:r>
-              <a:t>2. Askeri Test Sahası Desteği</a:t>
+              <a:t>2. Gerçekçi Askeri Test Alanı Desteği</a:t>
             </a:r>
           </a:p>
           <a:p>
@@ -6043,7 +6043,7 @@
               </a:defRPr>
             </a:pPr>
             <a:r>
-              <a:t>GPS uydularının kasıtlı olarak karartıldığı kontrollü askeri test sahalarında algoritmalarımızın başarısını resmi olarak kanıtlamak.</a:t>
+              <a:t>GPS uydularının kapalı olduğu kontrollü askeri test alanlarında yazılımımızın gücünü resmi olarak kanıtlamak.</a:t>
             </a:r>
           </a:p>
         </p:txBody>
@@ -6123,7 +6123,7 @@
               </a:defRPr>
             </a:pPr>
             <a:r>
-              <a:t>3. Yerli Yazılım Tedarikçi Sözleşmesi</a:t>
+              <a:t>3. Yerli Yazılım Tedarikçi Anlaşması</a:t>
             </a:r>
           </a:p>
           <a:p>
@@ -6135,7 +6135,7 @@
               </a:defRPr>
             </a:pPr>
             <a:r>
-              <a:t>Ön onayı tamamlanan Yazılım Geliştirme başvurumuzla birlikte ASELSAN'ın onaylı yazılım tedarikçisi olmak ve araç başı lisanslama modeliyle çalışmak.</a:t>
+              <a:t>Ön onayı tamamlanan Yazılım Geliştirme başvurumuzla birlikte ASELSAN'ın onaylı yazılım tedarikçisi olmak ve araç başı lisans modeliyle çalışmak.</a:t>
             </a:r>
           </a:p>
         </p:txBody>
@@ -6215,7 +6215,7 @@
               </a:defRPr>
             </a:pPr>
             <a:r>
-              <a:t>4. Askeri Standartlaşma ve Mentorluk</a:t>
+              <a:t>4. Askeri Standartlar ve Uzman Desteği</a:t>
             </a:r>
           </a:p>
           <a:p>
@@ -6227,7 +6227,7 @@
               </a:defRPr>
             </a:pPr>
             <a:r>
-              <a:t>Askeri çevre koşullarına ve güvenlik standartlarına uyum sürecinde ASELSAN uzmanlarının teknik tecrübesinden faydalanmak.</a:t>
+              <a:t>Askeri çevre koşullarına ve güvenlik kurallarına uyum sürecinde ASELSAN uzmanlarının tecrübesinden faydalanmak.</a:t>
             </a:r>
           </a:p>
         </p:txBody>
@@ -6385,7 +6385,7 @@
               </a:defRPr>
             </a:pPr>
             <a:r>
-              <a:t>ASELSAN ile birlikte muharebe sahasında Mehmetçiğin can güvenliğini milli otonomiyle korumak için hazırız.</a:t>
+              <a:t>ASELSAN ile birlikte sahada Mehmetçiğin can güvenliğini yerli otonomiyle korumak için hazırız.</a:t>
             </a:r>
           </a:p>
         </p:txBody>
@@ -6681,7 +6681,7 @@
               </a:defRPr>
             </a:pPr>
             <a:r>
-              <a:t>1. GPS Sinyalinin Kesilmesi veya Yanıltılması</a:t>
+              <a:t>1. Uydu (GPS) Sinyalinin Kesilmesi</a:t>
             </a:r>
           </a:p>
           <a:p>
@@ -6693,7 +6693,7 @@
               </a:defRPr>
             </a:pPr>
             <a:r>
-              <a:t>Savaş ve operasyon bölgelerinde sinyal bozucular GPS'i tamamen kesmektedir. Mevcut otonom araçlar uydu bağlantısı koptuğunda haritayı ve rotayı kaybedip hareketsiz kalmakta ve vurulmaya açık hedef olmaktadır.</a:t>
+              <a:t>Savaş ve operasyon alanlarında sinyal bozucular uydu bağlantısını tamamen keser. Pazardaki standart insansız araçlar uydu bağlantısı koptuğunda yönünü kaybedip durur ve açık hedef haline gelir.</a:t>
             </a:r>
           </a:p>
         </p:txBody>
@@ -6785,7 +6785,7 @@
               </a:defRPr>
             </a:pPr>
             <a:r>
-              <a:t>Uzaktan kumandayla yönlendirilen insansız araçların telsiz bağı koptuğunda araç olduğu yerde kilitlenmektedir. Ayrıca sinyalin gecikmeli gitmesi ani tehlikelerde kazalara yol açmaktadır.</a:t>
+              <a:t>Uzaktan kumandayla yönlendirilen araçlarda telsiz bağı koptuğunda araç olduğu yerde donup kalır. Ayrıca sinyalin gecikmeli gitmesi ani engellerde kazalara yol açar.</a:t>
             </a:r>
           </a:p>
         </p:txBody>
@@ -6865,7 +6865,7 @@
               </a:defRPr>
             </a:pPr>
             <a:r>
-              <a:t>3. Yabancı Otonomi Yazılımlarına Bağımlı Olunması</a:t>
+              <a:t>3. Yabancı Otonom Yazılımlara Bağımlılık</a:t>
             </a:r>
           </a:p>
           <a:p>
@@ -6877,7 +6877,7 @@
               </a:defRPr>
             </a:pPr>
             <a:r>
-              <a:t>Piyasadaki hazır otonom yazılımlar yabancı menşeilidir. Bu yazılımlar askeri savunma standartlarına uyum sağlamaz, siber güvenlik açıkları taşır ve Türk savunma sistemlerine doğrudan bağlanamaz.</a:t>
+              <a:t>Piyasadaki hazır otonom sistemler yabancı kaynaklıdır. Güvenlik açıkları taşır ve Türk savunma sanayii sistemleriyle doğrudan haberleşemez.</a:t>
             </a:r>
           </a:p>
         </p:txBody>
@@ -7102,7 +7102,7 @@
               </a:defRPr>
             </a:pPr>
             <a:r>
-              <a:t>1. GPS Olmadan Lazer (LiDAR) ile 3 Boyutlu Haritalama</a:t>
+              <a:t>1. Uydu Olmadan Lazer Gözlerle (LiDAR) Haritalama</a:t>
             </a:r>
           </a:p>
           <a:p>
@@ -7114,7 +7114,7 @@
               </a:defRPr>
             </a:pPr>
             <a:r>
-              <a:t>GPS uydusu tamamen kapansa bile; araç üzerindeki 3 boyutlu lazer tarayıcı (LiDAR) ve hareket sensörleri sayesinde araç kendi haritasını santim santim kendisi çıkarır ve rotasında kaybolmadan ilerler.</a:t>
+              <a:t>Uydu sinyali tamamen kesilse bile; araç üzerindeki 3 boyutlu lazer tarayıcılar sayesinde araç kendi haritasını arazide kendisi çıkarır ve yolundan şaşmadan ilerler.</a:t>
             </a:r>
           </a:p>
         </p:txBody>
@@ -7194,7 +7194,7 @@
               </a:defRPr>
             </a:pPr>
             <a:r>
-              <a:t>2. Telsiz Bağlantısı Koptuğunda Otonom Eve Dönüş</a:t>
+              <a:t>2. Bağlantı Koptuğunda Kendi Başına Üsse Dönüş</a:t>
             </a:r>
           </a:p>
           <a:p>
@@ -7206,7 +7206,7 @@
               </a:defRPr>
             </a:pPr>
             <a:r>
-              <a:t>Kumanda veya telsiz bağlantısı koptuğu anda araç panik yapmaz. Hafızasındaki lazer haritayı takip ederek güvenli başlangıç noktasına (üs bölgesine) kendi kendine geri döner.</a:t>
+              <a:t>Kumanda veya telsiz bağlantısı koptuğu anda araç panik yapmaz. Hafızasındaki lazer haritayı takip ederek güvenli başlangıç noktasına kendi kendine geri döner.</a:t>
             </a:r>
           </a:p>
         </p:txBody>
@@ -7298,7 +7298,7 @@
               </a:defRPr>
             </a:pPr>
             <a:r>
-              <a:t>Yazılımın tüm kodları sıfırdan yerli olarak geliştirilmiştir. Askeri haberleşme kurallarına ve ASELSAN kara sistemlerine doğrudan tak-çalıştır şeklinde bağlanabilir.</a:t>
+              <a:t>Yazılımın tüm satırları sıfırdan yerli olarak yazılmıştır. Askeri haberleşme kurallarına ve ASELSAN kara sistemlerine doğrudan bağlanabilir.</a:t>
             </a:r>
           </a:p>
         </p:txBody>
@@ -7398,7 +7398,7 @@
               </a:defRPr>
             </a:pPr>
             <a:r>
-              <a:t>ÜRÜN: Trustia Otonomi Beyni ve Taktik Kontrol Konsolu</a:t>
+              <a:t>ÜRÜN: Trustia Otonomi Beyni ve Kontrol Ekranı</a:t>
             </a:r>
           </a:p>
         </p:txBody>
@@ -7478,7 +7478,7 @@
               </a:defRPr>
             </a:pPr>
             <a:r>
-              <a:t>• Akıllı Sürüş ve Rota Planlayıcı: </a:t>
+              <a:t>• Akıllı Sürüş ve Rota Çizici: </a:t>
             </a:r>
             <a:r>
               <a:rPr sz="1200">
@@ -7486,7 +7486,7 @@
                   <a:srgbClr val="212529"/>
                 </a:solidFill>
               </a:rPr>
-              <a:t>Lazer sensörlerle çevreyi tarar, yoldaki çukurları, kayaları ve hareketli hedefleri anında algılayıp etrafından güvenle dolaşır.</a:t>
+              <a:t>Lazer sensörlerle çevreyi tarar; yoldaki çukurları, kayaları ve hareketli engelleri anında görüp etrafından dolaşır.</a:t>
             </a:r>
           </a:p>
           <a:p>
@@ -7498,7 +7498,7 @@
               </a:defRPr>
             </a:pPr>
             <a:r>
-              <a:t>• Askeri Tehlike Algılama Modülleri: </a:t>
+              <a:t>• Askeri Tehlike Algılama Modülü: </a:t>
             </a:r>
             <a:r>
               <a:rPr sz="1200">
@@ -7506,7 +7506,7 @@
                   <a:srgbClr val="212529"/>
                 </a:solidFill>
               </a:rPr>
-              <a:t>Yoldaki mayın veya el yapımı patlayıcı şüpheli cisimleri tespit eder ve 30 metre geriden aracı durdurup güvenli bölgeye alır.</a:t>
+              <a:t>Yoldaki mayın ve patlayıcı şüpheli cisimleri tespit eder, aracı güvenli mesafede durdurur.</a:t>
             </a:r>
           </a:p>
           <a:p>
@@ -7518,7 +7518,7 @@
               </a:defRPr>
             </a:pPr>
             <a:r>
-              <a:t>• Taktik Komuta Konsolu (Ekran): </a:t>
+              <a:t>• Taktik Komuta Ekranı: </a:t>
             </a:r>
             <a:r>
               <a:rPr sz="1200">
@@ -7526,7 +7526,7 @@
                   <a:srgbClr val="212529"/>
                 </a:solidFill>
               </a:rPr>
-              <a:t>Askeri harita destekli komuta ekranı. Operatör tablet üzerinden tek tıkla araca hedef verir veya acil durumda anında durdurur.</a:t>
+              <a:t>Askeri harita destekli kontrol ekranı. Operatör ekran üzerinden tek dokunuşla araca hedef verir veya anında durdurur.</a:t>
             </a:r>
           </a:p>
           <a:p>
@@ -7546,7 +7546,7 @@
                   <a:srgbClr val="212529"/>
                 </a:solidFill>
               </a:rPr>
-              <a:t>16.000 satırlık yazılım çekirdeği 1.301 farklı zorlu kaza ve arazi senaryosunda test edilmiş ve %100 başarıyla tamamlanmıştır.</a:t>
+              <a:t>16 bin satırlık yazılım çekirdeği 1.301 farklı zorlu arazi senaryosunda test edilmiş ve tamamını hatasız geçmiştir.</a:t>
             </a:r>
           </a:p>
         </p:txBody>
@@ -7650,7 +7650,7 @@
               </a:defRPr>
             </a:pPr>
             <a:r>
-              <a:t>TEKNİK ÖZELLİKLER</a:t>
+              <a:t>TEKNİK GÜCÜMÜZ</a:t>
             </a:r>
           </a:p>
           <a:p>
@@ -7662,7 +7662,7 @@
               </a:defRPr>
             </a:pPr>
             <a:r>
-              <a:t>✓ Haberleşme: Askeri ve Robot Standartları Uyumlu</a:t>
+              <a:t>✓ Haberleşme: Askeri ve Robotik Standartlara Tam Uyumlu</a:t>
             </a:r>
           </a:p>
           <a:p>
@@ -7674,7 +7674,7 @@
               </a:defRPr>
             </a:pPr>
             <a:r>
-              <a:t>✓ Bilgisayar: Nvidia Jetson ve Endüstriyel PC'ler</a:t>
+              <a:t>✓ Bilgisayar: Araç İçi Güçlü İşlemciler (Nvidia Jetson vb.)</a:t>
             </a:r>
           </a:p>
           <a:p>
@@ -7686,7 +7686,7 @@
               </a:defRPr>
             </a:pPr>
             <a:r>
-              <a:t>✓ Sensörler: 3D Lazer (LiDAR), Kamera, Hareket Sensörü</a:t>
+              <a:t>✓ Sensörler: 3 Boyutlu Lazer (LiDAR), Kamera, Açı Ölçerler</a:t>
             </a:r>
           </a:p>
           <a:p>
@@ -7698,7 +7698,7 @@
               </a:defRPr>
             </a:pPr>
             <a:r>
-              <a:t>✓ Tepki Hızı: 5 Milisaniyede Müdahale Edebilme</a:t>
+              <a:t>✓ Tepki Hızı: 5 Milisaniyede (Göz Kırpmasından Hızlı) Müdahale</a:t>
             </a:r>
           </a:p>
           <a:p>
@@ -7710,7 +7710,7 @@
               </a:defRPr>
             </a:pPr>
             <a:r>
-              <a:t>✓ Durum: Çalışır Prototip, Teste Hazır</a:t>
+              <a:t>✓ Durum: Çalışır Durumda, Göreve Hazır</a:t>
             </a:r>
           </a:p>
         </p:txBody>
@@ -7810,7 +7810,7 @@
               </a:defRPr>
             </a:pPr>
             <a:r>
-              <a:t>ALTYAPILAR: Test Parkımız ve Resmi Tescillerimiz</a:t>
+              <a:t>ALTYAPILAR: Çalışma Merkezimiz ve Belgelerimiz</a:t>
             </a:r>
           </a:p>
         </p:txBody>
@@ -7947,7 +7947,7 @@
               </a:defRPr>
             </a:pPr>
             <a:r>
-              <a:t>İstanbul Ticaret Odası bünyesindeki Fulya Derin Teknoloji Kampüsü'nde sözleşmeli kuluçka merkezimiz. Ar-Ge, yazılım ve laboratuvar altyapımız buradadır.</a:t>
+              <a:t>İstanbul Ticaret Odası bünyesindeki Fulya Derin Teknoloji Kampüsü'nde yerleşik merkezimiz. Ar-Ge, yazılım ve çalışma alanımız buradadır.</a:t>
             </a:r>
           </a:p>
         </p:txBody>
@@ -8039,7 +8039,7 @@
               </a:defRPr>
             </a:pPr>
             <a:r>
-              <a:t>Yapay zeka araç bilgisayarları (Jetson Orin), 3 boyutlu lazer tarayıcılar (LiDAR), açı ölçer sensörler ve araç içi elektronik bağlantı kablolama ekipmanlarımız mevcuttur.</a:t>
+              <a:t>Araç bilgisayarları, 3 boyutlu lazer tarayıcılar (LiDAR), yön algılayıcı sensörler ve araç içi bağlantı ekipmanlarımız mevcuttur.</a:t>
             </a:r>
           </a:p>
         </p:txBody>
@@ -8131,7 +8131,7 @@
               </a:defRPr>
             </a:pPr>
             <a:r>
-              <a:t>Gerçek dünyaya çıkmadan önce yazılımımızı 1.301 farklı simülasyon senaryosunda (sis, çamur, gece, radar karıştırması) 43 saniyede otomatik test eden sistemimiz aktiftir.</a:t>
+              <a:t>Gerçek araziye çıkmadan önce yazılımımızı 1.301 farklı sanal senaryoda (sis, çamur, gece, karıştırma) 43 saniyede otomatik test eden sistemimiz aktiftir.</a:t>
             </a:r>
           </a:p>
         </p:txBody>
@@ -8211,7 +8211,7 @@
               </a:defRPr>
             </a:pPr>
             <a:r>
-              <a:t>Resmi Akreditasyonlar</a:t>
+              <a:t>Resmi Belgelerimiz ve Onaylarımız</a:t>
             </a:r>
           </a:p>
           <a:p>
@@ -8223,7 +8223,7 @@
               </a:defRPr>
             </a:pPr>
             <a:r>
-              <a:t>ASELSAN Potansiyel Tedarikçi Onayı (SAP: FZQHEXGFMTJU), NATO Askeri Tedarikçi Başvurusu (NCAGE), TÜBİTAK ARBİS Kaydı ve Savunma Sanayii Sertifikalarımız.</a:t>
+              <a:t>ASELSAN Tedarikçi Portalı Yazılım Ön Onayı (SAP: FZQHEXGFMTJU), NATO Tedarikçi Kodu Başvurusu, TÜBİTAK ARBİS Kaydı ve Savunma Sanayii Sertifikalarımız.</a:t>
             </a:r>
           </a:p>
         </p:txBody>
@@ -8448,7 +8448,7 @@
               </a:defRPr>
             </a:pPr>
             <a:r>
-              <a:t>DÜNYA PAZARI (TAM)</a:t>
+              <a:t>DÜNYA PAZARI</a:t>
             </a:r>
           </a:p>
           <a:p>
@@ -8552,7 +8552,7 @@
               </a:defRPr>
             </a:pPr>
             <a:r>
-              <a:t>BÖLGESEL PAZAR (SAM)</a:t>
+              <a:t>BÖLGEMİZDEKİ PAZAR</a:t>
             </a:r>
           </a:p>
           <a:p>
@@ -8576,7 +8576,7 @@
               </a:defRPr>
             </a:pPr>
             <a:r>
-              <a:t>Türkiye, NATO ve dost ülkelerdeki sınır güvenliği, otonom konvoy ve taktik araç yazılımları pazarı.</a:t>
+              <a:t>Türkiye, NATO ve bölge ülkelerindeki sınır güvenliği, otonom konvoy ve taktik araç yazılımları pazarı.</a:t>
             </a:r>
           </a:p>
         </p:txBody>
@@ -8656,7 +8656,7 @@
               </a:defRPr>
             </a:pPr>
             <a:r>
-              <a:t>BİZİM HEDEFİMİZ (SOM)</a:t>
+              <a:t>BİZİM HEDEFİMİZ</a:t>
             </a:r>
           </a:p>
           <a:p>
@@ -8680,7 +8680,7 @@
               </a:defRPr>
             </a:pPr>
             <a:r>
-              <a:t>ASELSAN ve TSK kara araçlarının otonomlaştırılması projelerinde ilk 3 yılda hedeflediğimiz yerli yazılım payı.</a:t>
+              <a:t>ASELSAN ve yerli kara araçlarının otonomlaştırılması projelerinde ilk 3 yılda hedeflediğimiz yerli yazılım payı.</a:t>
             </a:r>
           </a:p>
         </p:txBody>
@@ -8780,7 +8780,7 @@
               </a:defRPr>
             </a:pPr>
             <a:r>
-              <a:t>RAKİP ANALİZİ: Taktik Saha İhtiyaçları Karşılaştırması</a:t>
+              <a:t>FARKIMIZ: Sahadaki Çözümlerle Karşılaştırma</a:t>
             </a:r>
           </a:p>
         </p:txBody>
@@ -8868,7 +8868,7 @@
                         </a:defRPr>
                       </a:pPr>
                       <a:r>
-                        <a:t>Özellik / Yetenek</a:t>
+                        <a:t>Özellik ve Yetenek</a:t>
                       </a:r>
                     </a:p>
                   </a:txBody>
@@ -8891,7 +8891,7 @@
                         </a:defRPr>
                       </a:pPr>
                       <a:r>
-                        <a:t>TRUSTIA AI (Yerli)</a:t>
+                        <a:t>TRUSTIA (Yerli Yazılım)</a:t>
                       </a:r>
                     </a:p>
                   </a:txBody>
@@ -8914,7 +8914,7 @@
                         </a:defRPr>
                       </a:pPr>
                       <a:r>
-                        <a:t>Klasik Uzaktan Kumanda</a:t>
+                        <a:t>Klasik Kumandalı Araçlar</a:t>
                       </a:r>
                     </a:p>
                   </a:txBody>
@@ -8962,7 +8962,7 @@
                         </a:defRPr>
                       </a:pPr>
                       <a:r>
-                        <a:t>GPS Olmadan Haritalama (Lazerle)</a:t>
+                        <a:t>Uydusuz Lazerle Harita Çıkarma</a:t>
                       </a:r>
                     </a:p>
                   </a:txBody>
@@ -8985,7 +8985,7 @@
                         </a:defRPr>
                       </a:pPr>
                       <a:r>
-                        <a:t>✓ Tam Uyumlu</a:t>
+                        <a:t>✓ Tam Uyumlu (Lazerle Gider)</a:t>
                       </a:r>
                     </a:p>
                   </a:txBody>
@@ -9008,7 +9008,7 @@
                         </a:defRPr>
                       </a:pPr>
                       <a:r>
-                        <a:t>✗ Yok (GPS Şart)</a:t>
+                        <a:t>✗ Yok (Uydu Şart)</a:t>
                       </a:r>
                     </a:p>
                   </a:txBody>
@@ -9031,7 +9031,7 @@
                         </a:defRPr>
                       </a:pPr>
                       <a:r>
-                        <a:t>△ Şehir Haritası Şart</a:t>
+                        <a:t>△ Şehir Haritası İster</a:t>
                       </a:r>
                     </a:p>
                   </a:txBody>
@@ -9056,7 +9056,7 @@
                         </a:defRPr>
                       </a:pPr>
                       <a:r>
-                        <a:t>Askeri ve NATO Standartlarına Uyum</a:t>
+                        <a:t>Askeri Standartlara Uyum</a:t>
                       </a:r>
                     </a:p>
                   </a:txBody>
@@ -9102,7 +9102,7 @@
                         </a:defRPr>
                       </a:pPr>
                       <a:r>
-                        <a:t>△ Standartsız Telsiz</a:t>
+                        <a:t>△ Sadece Telsiz</a:t>
                       </a:r>
                     </a:p>
                   </a:txBody>
@@ -9125,7 +9125,7 @@
                         </a:defRPr>
                       </a:pPr>
                       <a:r>
-                        <a:t>✗ Askeri Uyum Yok</a:t>
+                        <a:t>✗ Askeri Standart Yok</a:t>
                       </a:r>
                     </a:p>
                   </a:txBody>
@@ -9150,7 +9150,7 @@
                         </a:defRPr>
                       </a:pPr>
                       <a:r>
-                        <a:t>%100 Yerli Kod Bağımsızlığı</a:t>
+                        <a:t>%100 Yerli Kod Güvencesi</a:t>
                       </a:r>
                     </a:p>
                   </a:txBody>
@@ -9196,7 +9196,7 @@
                         </a:defRPr>
                       </a:pPr>
                       <a:r>
-                        <a:t>△ Donanıma Bağımlı</a:t>
+                        <a:t>△ Parçalara Bağımlı</a:t>
                       </a:r>
                     </a:p>
                   </a:txBody>
@@ -9219,7 +9219,7 @@
                         </a:defRPr>
                       </a:pPr>
                       <a:r>
-                        <a:t>✗ Yabancı Bağımlı</a:t>
+                        <a:t>✗ Yabancıya Bağımlı</a:t>
                       </a:r>
                     </a:p>
                   </a:txBody>
@@ -9244,7 +9244,7 @@
                         </a:defRPr>
                       </a:pPr>
                       <a:r>
-                        <a:t>Bağlantı Kopunca Kendi Kendine Dönüş</a:t>
+                        <a:t>Bağlantı Kopunca Eve Dönüş</a:t>
                       </a:r>
                     </a:p>
                   </a:txBody>
@@ -9267,7 +9267,7 @@
                         </a:defRPr>
                       </a:pPr>
                       <a:r>
-                        <a:t>✓ Otonom Eve Dönüş</a:t>
+                        <a:t>✓ Kendi Kendine Döner</a:t>
                       </a:r>
                     </a:p>
                   </a:txBody>
@@ -9338,7 +9338,7 @@
                         </a:defRPr>
                       </a:pPr>
                       <a:r>
-                        <a:t>1.301 Testli Doğrulanmış Prototip</a:t>
+                        <a:t>1.301 Testten Geçmiş Sistem</a:t>
                       </a:r>
                     </a:p>
                   </a:txBody>
@@ -9654,7 +9654,7 @@
               </a:defRPr>
             </a:pPr>
             <a:r>
-              <a:t>ASELSAN'ın ürettiği veya modernize ettiği her bir insansız kara aracı başına otonomi yazılımı lisans bedeli faturalandırılması.</a:t>
+              <a:t>ASELSAN'ın ürettiği veya modernize ettiği her insansız araç başına yazılım lisans bedeli faturalandırılması.</a:t>
             </a:r>
           </a:p>
         </p:txBody>
@@ -9734,7 +9734,7 @@
               </a:defRPr>
             </a:pPr>
             <a:r>
-              <a:t>2. Özel Görev Modülleri Satışı</a:t>
+              <a:t>2. İlave Güvenlik Paketleri</a:t>
             </a:r>
           </a:p>
           <a:p>
@@ -9746,7 +9746,7 @@
               </a:defRPr>
             </a:pPr>
             <a:r>
-              <a:t>Temel sürüşe ek olarak; Mayın Tespit Paketi, Zehirli Gaz Kaçınma Paketi veya Sürü Halinde İlerleme Paketi gibi ilave yazılım modülleri satışı.</a:t>
+              <a:t>Temel sürüşe ek olarak; Mayın Arama Paketi, Gaz Kaçınma Paketi veya Sürü Halinde İlerleme Paketi gibi ilave yazılım modülleri satışı.</a:t>
             </a:r>
           </a:p>
         </p:txBody>
@@ -9826,7 +9826,7 @@
               </a:defRPr>
             </a:pPr>
             <a:r>
-              <a:t>3. Entegrasyon, Saha Testi ve Yıllık Bakım Anlaşmaları</a:t>
+              <a:t>3. Araç Montajı, Saha Testi ve Yıllık Bakım</a:t>
             </a:r>
           </a:p>
           <a:p>
@@ -9838,7 +9838,7 @@
               </a:defRPr>
             </a:pPr>
             <a:r>
-              <a:t>Yeni zırhlı araçlara sensör ve yazılım bağlama mühendisliği, arazide test desteği ve yıllık yazılım güncelleme/bakım sözleşmeleri.</a:t>
+              <a:t>Yeni araçlara sensör ve yazılım bağlama desteği, arazide test desteği ve yıllık yazılım güncelleme/bakım sözleşmeleri.</a:t>
             </a:r>
           </a:p>
         </p:txBody>
@@ -9938,7 +9938,7 @@
               </a:defRPr>
             </a:pPr>
             <a:r>
-              <a:t>PAZARA GİRİŞ STRATEJİSİ: Adım Adım Büyüme Planımız</a:t>
+              <a:t>PAZARA GİRİŞ: Adım Adım Büyüme Planımız</a:t>
             </a:r>
           </a:p>
         </p:txBody>
@@ -10063,7 +10063,7 @@
               </a:defRPr>
             </a:pPr>
             <a:r>
-              <a:t>1. Aşama: ASELSAN Araçlarında Saha Testi (2026)</a:t>
+              <a:t>1. Aşama: ASELSAN Araçlarında Saha Denemesi (2026)</a:t>
             </a:r>
           </a:p>
           <a:p>
@@ -10075,7 +10075,7 @@
               </a:defRPr>
             </a:pPr>
             <a:r>
-              <a:t>ASELSAN Girişimcilik Merkezi (Axcelerate) desteğiyle ASELSAN'ın taktik kara araçlarında yazılımımızı arazide test edip ilk ortak başarıyı yakalamak.</a:t>
+              <a:t>ASELSAN Girişimcilik Merkezi (Axcelerate) desteğiyle ASELSAN taktik kara araçlarında yazılımımızı arazide denemek ve ilk ortak başarıyı yakalamak.</a:t>
             </a:r>
           </a:p>
         </p:txBody>
@@ -10155,7 +10155,7 @@
               </a:defRPr>
             </a:pPr>
             <a:r>
-              <a:t>2. Aşama: Türk Savunma Sanayii Araçlarına Yayılım (2027)</a:t>
+              <a:t>2. Aşama: Türk Savunma Sanayii Araçlarına Yayılma (2027)</a:t>
             </a:r>
           </a:p>
           <a:p>
@@ -10167,7 +10167,7 @@
               </a:defRPr>
             </a:pPr>
             <a:r>
-              <a:t>ASELSAN onaylı tedarikçi gücüyle; zırhlı araç üreticilerinin (FNSS, BMC, vb.) tekerlekli ve paletli araçlarına otonom devriye ve konvoy beyni sağlamak.</a:t>
+              <a:t>ASELSAN onaylı tedarikçi gücüyle; yerli zırhlı araç üreticilerinin araçlarına otonom devriye ve konvoy yazılımı sağlamak.</a:t>
             </a:r>
           </a:p>
         </p:txBody>
@@ -10247,7 +10247,7 @@
               </a:defRPr>
             </a:pPr>
             <a:r>
-              <a:t>3. Aşama: Dost ve Müttefik Ülkelere İhracat (2027-2028)</a:t>
+              <a:t>3. Aşama: Dost Ülkelere İhracat (2027-2028)</a:t>
             </a:r>
           </a:p>
           <a:p>
@@ -10259,7 +10259,7 @@
               </a:defRPr>
             </a:pPr>
             <a:r>
-              <a:t>NATO tedarikçi kodumuz ve uluslararası patent korumamızla, dost ülke ordularının insansız araç projelerine milli yazılımımızı ihraç etmek.</a:t>
+              <a:t>NATO tedarikçi kodumuz ve tescillerimizle, dost ülke ordularının projelerine yerli yazılımımızı ihraç etmek.</a:t>
             </a:r>
           </a:p>
         </p:txBody>

</xml_diff>

<commit_message>
Donanim sahipligi yerine donanim bagimsiz yazilim altyapisi vurgusu eklendi
</commit_message>
<xml_diff>
--- a/Kurumsal/Sunumlar/Trustia_ASELSAN_Girisim_Sunumu.pptx
+++ b/Kurumsal/Sunumlar/Trustia_ASELSAN_Girisim_Sunumu.pptx
@@ -7650,7 +7650,7 @@
               </a:defRPr>
             </a:pPr>
             <a:r>
-              <a:t>TEKNİK GÜCÜMÜZ</a:t>
+              <a:t>TEKNİK UYUMLULUK</a:t>
             </a:r>
           </a:p>
           <a:p>
@@ -7674,7 +7674,7 @@
               </a:defRPr>
             </a:pPr>
             <a:r>
-              <a:t>✓ Bilgisayar: Araç İçi Güçlü İşlemciler (Nvidia Jetson vb.)</a:t>
+              <a:t>✓ Bilgisayar: Nvidia Jetson ve Araç İçi Bilgisayarlarla Uyumlu</a:t>
             </a:r>
           </a:p>
           <a:p>
@@ -7686,7 +7686,7 @@
               </a:defRPr>
             </a:pPr>
             <a:r>
-              <a:t>✓ Sensörler: 3 Boyutlu Lazer (LiDAR), Kamera, Açı Ölçerler</a:t>
+              <a:t>✓ Sensörler: Her Marka Lazer (LiDAR) ve Kamerayla Çalışabilir</a:t>
             </a:r>
           </a:p>
           <a:p>
@@ -7710,7 +7710,7 @@
               </a:defRPr>
             </a:pPr>
             <a:r>
-              <a:t>✓ Durum: Çalışır Durumda, Göreve Hazır</a:t>
+              <a:t>✓ Durum: Yazılım Hazır, 1.301 Testten Geçti</a:t>
             </a:r>
           </a:p>
         </p:txBody>
@@ -8027,7 +8027,7 @@
               </a:defRPr>
             </a:pPr>
             <a:r>
-              <a:t>Yazılım ve Donanım Test Cihazları</a:t>
+              <a:t>Donanım Bağımsız Yazılım Altyapısı</a:t>
             </a:r>
           </a:p>
           <a:p>
@@ -8039,7 +8039,7 @@
               </a:defRPr>
             </a:pPr>
             <a:r>
-              <a:t>Araç bilgisayarları, 3 boyutlu lazer tarayıcılar (LiDAR), yön algılayıcı sensörler ve araç içi bağlantı ekipmanlarımız mevcuttur.</a:t>
+              <a:t>Biz yazılım şirketiyiz. Kodlarımız donanım bağımsızdır; ASELSAN'ın araçlarındaki her marka lazer (LiDAR), kamera ve araç bilgisayarına doğrudan tak-çalıştır bağlanır.</a:t>
             </a:r>
           </a:p>
         </p:txBody>

</xml_diff>

<commit_message>
Slide 11 yapay zeka destekli sistem mimarisi olarak guncellendi
</commit_message>
<xml_diff>
--- a/Kurumsal/Sunumlar/Trustia_ASELSAN_Girisim_Sunumu.pptx
+++ b/Kurumsal/Sunumlar/Trustia_ASELSAN_Girisim_Sunumu.pptx
@@ -5586,11 +5586,11 @@
               </a:defRPr>
             </a:pPr>
             <a:r>
-              <a:t>• 16.000 satırlık Trustia Otonomi Çekirdeğinin mimarı ve yazarı.</a:t>
+              <a:t>• İleri yapay zeka araçlarıyla 16.000 satırlık otonomi çekirdeğini inşa eden Sistem Mimarı.</a:t>
             </a:r>
             <a:br/>
             <a:r>
-              <a:t>• 1.301 otomatik test senaryosunun geliştiricisi (%100 başarı).</a:t>
+              <a:t>• 1.301 otomatik güvenlik testinin tasarımcısı ve yöneticisi (%100 başarı).</a:t>
             </a:r>
             <a:br/>
             <a:r>
@@ -5598,7 +5598,7 @@
             </a:r>
             <a:br/>
             <a:r>
-              <a:t>• Çekirdek Yazılım, Rota Planlama ve Algoritma Lideri.</a:t>
+              <a:t>• Yapay Zeka Destekli Yazılım ve Algoritma Lideri.</a:t>
             </a:r>
           </a:p>
         </p:txBody>

</xml_diff>

<commit_message>
Denizcan universite ve basari bilgileri Slide 11'e eklendi
</commit_message>
<xml_diff>
--- a/Kurumsal/Sunumlar/Trustia_ASELSAN_Girisim_Sunumu.pptx
+++ b/Kurumsal/Sunumlar/Trustia_ASELSAN_Girisim_Sunumu.pptx
@@ -5706,11 +5706,15 @@
             </a:r>
             <a:br/>
             <a:r>
-              <a:t>• TEKNOFEST Robotaksi Finalisti.</a:t>
+              <a:t>• İstanbul Üniversitesi-Cerrahpaşa (İÜC) EEE (3.44 GPA).</a:t>
             </a:r>
             <a:br/>
             <a:r>
-              <a:t>• Lazer tarayıcılar (LiDAR), sensörler, gömülü bilgisayarlar ve araç içi haberleşme uzmanı.</a:t>
+              <a:t>• TEKNOFEST Robotaksi Otonom Araç Yarışması Finalisti.</a:t>
+            </a:r>
+            <a:br/>
+            <a:r>
+              <a:t>• Lazer tarayıcılar (LiDAR), sensörler, gömülü bilgisayarlar uzmanı.</a:t>
             </a:r>
             <a:br/>
             <a:r>

</xml_diff>

<commit_message>
Denizcan gercek CV basarilari eklendi ve kisaltmalar temizlendi
</commit_message>
<xml_diff>
--- a/Kurumsal/Sunumlar/Trustia_ASELSAN_Girisim_Sunumu.pptx
+++ b/Kurumsal/Sunumlar/Trustia_ASELSAN_Girisim_Sunumu.pptx
@@ -5586,7 +5586,7 @@
               </a:defRPr>
             </a:pPr>
             <a:r>
-              <a:t>• İleri yapay zeka araçlarıyla 16.000 satırlık otonomi çekirdeğini inşa eden Sistem Mimarı.</a:t>
+              <a:t>• İleri yapay zeka kodlama araçlarıyla 16.000 satırlık otonomi çekirdeğini inşa eden Sistem Mimarı.</a:t>
             </a:r>
             <a:br/>
             <a:r>
@@ -5594,11 +5594,15 @@
             </a:r>
             <a:br/>
             <a:r>
-              <a:t>• TÜBİTAK ARBİS, BTK Savunma ve KOSGEB İleri Girişimci tescilleri sahibi.</a:t>
+              <a:t>• TÜBİTAK ARBİS, BTK Savunma Sanayii ve KOSGEB İleri Girişimci tescilleri sahibi.</a:t>
             </a:r>
             <a:br/>
             <a:r>
-              <a:t>• Yapay Zeka Destekli Yazılım ve Algoritma Lideri.</a:t>
+              <a:t>• İTO BTM Fulya Girişimcilik Merkezi yerleşik derin teknoloji proje lideri.</a:t>
+            </a:r>
+            <a:br/>
+            <a:r>
+              <a:t>• Çekirdek yazılım, lazerle haritalama ve algoritma lideri.</a:t>
             </a:r>
           </a:p>
         </p:txBody>
@@ -5702,23 +5706,27 @@
               </a:defRPr>
             </a:pPr>
             <a:r>
-              <a:t>• ASELSAN Aday Mühendislik Havuzu Üyesi.</a:t>
+              <a:t>• ASELSAN Haberleşme ve Bilgi Teknolojileri bünyesinde Donanım Mühendisi.</a:t>
             </a:r>
             <a:br/>
             <a:r>
-              <a:t>• İstanbul Üniversitesi-Cerrahpaşa (İÜC) EEE (3.44 GPA).</a:t>
+              <a:t>• İstanbul Üniversitesi-Cerrahpaşa Elektrik-Elektronik Mühendisliği (4. Sınıf).</a:t>
             </a:r>
             <a:br/>
             <a:r>
-              <a:t>• TEKNOFEST Robotaksi Otonom Araç Yarışması Finalisti.</a:t>
+              <a:t>• ASELSAN Hava Savunma Sistemleri: 520 takım arasında 5.lik ve Kaptanlık.</a:t>
             </a:r>
             <a:br/>
             <a:r>
-              <a:t>• Lazer tarayıcılar (LiDAR), sensörler, gömülü bilgisayarlar uzmanı.</a:t>
+              <a:t>• TEKNOFEST Robotaksi: Otonom binek araç ve lazerli (LiDAR) sürüş finalisti.</a:t>
             </a:r>
             <a:br/>
             <a:r>
-              <a:t>• Donanım Kurulumu ve Saha Testleri Lideri.</a:t>
+              <a:t>• ROKETSAN: Su altı roket ve navigasyon sistemlerinde yazılım kaptanı.</a:t>
+            </a:r>
+            <a:br/>
+            <a:r>
+              <a:t>• Lazer tarayıcılar (LiDAR), araç haberleşmesi ve donanım kurulumu lideri.</a:t>
             </a:r>
           </a:p>
         </p:txBody>

</xml_diff>